<commit_message>
Fix AITC deck QR codes (paper, LinkedIn); trim presenter notes to cue blocks
</commit_message>
<xml_diff>
--- a/slides/confirming_process_aitc_2026_slides.pptx
+++ b/slides/confirming_process_aitc_2026_slides.pptx
@@ -528,7 +528,27 @@
           <a:p>
             <a:pPr/>
             <a:r>
-              <a:t>Hi everyone. I'm Brian Moriarty from Stevens Institute of Technology, in New Jersey. I work on human oversight of AI systems. This is a paper about a gap in how AI transparency and control infrastructure observes that oversight function. The short version. Governance records show that review happened. They don't show whether the review was substantive. And the two states are observationally identical. I want you holding that idea by the end of the opener.</a:t>
+              <a:t>S1  15-20s  SLOW, settle the room  (no 'thanks for having me')</a:t>
+            </a:r>
+          </a:p>
+          <a:p>
+            <a:r>
+              <a:t>- Brian Moriarty, Stevens - human oversight of AI, from IT architecture + governance</a:t>
+            </a:r>
+          </a:p>
+          <a:p>
+            <a:r>
+              <a:t>- the paper = a gap in how we OBSERVE the oversight function (inside the transparency + control infra we already use)</a:t>
+            </a:r>
+          </a:p>
+          <a:p>
+            <a:r>
+              <a:t>- records show review OCCURRED, not whether it was SUBSTANTIVE (unless someone notices)</a:t>
+            </a:r>
+          </a:p>
+          <a:p>
+            <a:r>
+              <a:t>- the two cases - real review vs rubber stamp - look identical from the outside</a:t>
             </a:r>
           </a:p>
         </p:txBody>
@@ -598,7 +618,47 @@
           <a:p>
             <a:pPr/>
             <a:r>
-              <a:t>Here are two sample governance records from an AI-assisted review workflow. Both show a review occurred. Both show approval was granted. Both pass audit. One of these reviewers actually engaged with the output. One signed off in six seconds. Current governance infrastructure cannot tell you which is which. The pattern shows up everywhere process records get used as evidence of substantive work. I have reviewed code commits whose entire commit message was the letter D. The system required a commit message. A character had been entered. Compliance was logged. Nothing about the substantive work the message was supposed to capture had survived. Same pattern, different domain. This is partly a fact about people. Humans can perform substantive review or procedural confirmation, and from the outside the two can look identical. That observation is older than AI. What the paper develops is a structural property of the infrastructure that wraps the oversight function in AI-assisted workflows. It doesn't even try to surface the difference. It instruments the model and the artifacts the model produces. It does not instrument the cognitive function that gives human oversight its safety value. The human side and the infrastructure side compound. This talk is about why that gap matters, and what a measurement agenda for closing it looks like.</a:t>
+              <a:t>S2  75-90s  EARN THE ROOM</a:t>
+            </a:r>
+          </a:p>
+          <a:p>
+            <a:r>
+              <a:t>[PAUSE 3-5s after click - let them read]</a:t>
+            </a:r>
+          </a:p>
+          <a:p>
+            <a:r>
+              <a:t>- two sample records (abstractions from my finance work) / both pass audit / one engaged ~18 min, one signed off in 6 sec / infra can't tell which</a:t>
+            </a:r>
+          </a:p>
+          <a:p>
+            <a:r>
+              <a:t>[PAUSE after 'six seconds']</a:t>
+            </a:r>
+          </a:p>
+          <a:p>
+            <a:r>
+              <a:t>- partly about people - a human-nature matter, older than AI (the 'D' commit msg if you want it)</a:t>
+            </a:r>
+          </a:p>
+          <a:p>
+            <a:r>
+              <a:t>- the structural point: infra instruments the model + its artifacts, not the cognitive work that gives oversight its safety value</a:t>
+            </a:r>
+          </a:p>
+          <a:p>
+            <a:r>
+              <a:t>- human side + infra side COMPOUND -&gt; the measurement agenda</a:t>
+            </a:r>
+          </a:p>
+          <a:p>
+            <a:r>
+              <a:t>- [if asked on time] time = crudest proxy, gamed (tab open 18 min, nothing happened); engagement not observable -&gt; seeded catch-rate + structural conditions</a:t>
+            </a:r>
+          </a:p>
+          <a:p>
+            <a:r>
+              <a:t>(don't speak over their reading; don't apologize for the samples)</a:t>
             </a:r>
           </a:p>
         </p:txBody>
@@ -668,7 +728,27 @@
           <a:p>
             <a:pPr/>
             <a:r>
-              <a:t>Three claims hold up the paper. First, human oversight should be treated the way supervisory control theory treats any operator function, as a system component with state, workload, calibration, and characterizable failure modes. Not as a binary that's either present or absent. Second, oversight degrades on a predictable trajectory under operational conditions, and the degraded state and the engaged state are observationally identical in current governance records. Third, detection, interpretability, and governance each have real value, but none of them close this specific gap, because they instrument the model and its outputs rather than the oversight function. The fix is to extend transparency and control work to include the oversight layer itself.</a:t>
+              <a:t>S3  60s  three claims, #2 is the anchor</a:t>
+            </a:r>
+          </a:p>
+          <a:p>
+            <a:r>
+              <a:t>- 1: oversight is a system component, not an on/off switch (supervisory control: state / workload / calibration / failure modes)</a:t>
+            </a:r>
+          </a:p>
+          <a:p>
+            <a:r>
+              <a:t>- 2 [SLOW, FULL FORM]: it degrades predictably; the degraded reviewer and the engaged reviewer are observationally identical, absent demonstrative evidence</a:t>
+            </a:r>
+          </a:p>
+          <a:p>
+            <a:r>
+              <a:t>- 3: detection / interpretability / governance watch the wrong layer (model + outputs); extend that transparency to the oversight layer itself</a:t>
+            </a:r>
+          </a:p>
+          <a:p>
+            <a:r>
+              <a:t>-&gt; bridge to 4 (only if room lost): 'Take claim two first.'</a:t>
             </a:r>
           </a:p>
         </p:txBody>
@@ -738,7 +818,32 @@
           <a:p>
             <a:pPr/>
             <a:r>
-              <a:t>The trajectory is three phases. Phase 1 is substantive engagement. The validation checkpoint is a genuine quality gate. Phase 2 is procedural scanning. The form of review persists. Scrutiny has been replaced by pattern recognition. Correction rates fall, not because quality improved, but because the threshold for intervention rose. Phase 3 is formality. Approval is recorded without substantive evaluation. The human role has shifted from controller to confirmer. Here is the part that matters. The governance record above the timeline does not change. Phase 1 and Phase 3 are operationally identical in the audit record. An external audit would find every required step documented, every approval recorded, every required party involved. The system that was designed to detect non-compliance does not register this. There is no alarm trigger, no threshold crossing, no incident.</a:t>
+              <a:t>S4  75-90s  SECOND REVEAL</a:t>
+            </a:r>
+          </a:p>
+          <a:p>
+            <a:r>
+              <a:t>- P1 substantive: corrections track quality</a:t>
+            </a:r>
+          </a:p>
+          <a:p>
+            <a:r>
+              <a:t>- P2 procedural: scanning replaces scrutiny; correction rate drops because the BAR ROSE, not the work</a:t>
+            </a:r>
+          </a:p>
+          <a:p>
+            <a:r>
+              <a:t>- P3 formality: approval logged with nothing behind it - controller -&gt; confirmer</a:t>
+            </a:r>
+          </a:p>
+          <a:p>
+            <a:r>
+              <a:t>[POINT at top bar, HOLD] record identical P1 = P3; audit finds every step documented, every approval logged</a:t>
+            </a:r>
+          </a:p>
+          <a:p>
+            <a:r>
+              <a:t>[PAUSE] no alarm, no threshold crossed, no incident</a:t>
             </a:r>
           </a:p>
         </p:txBody>
@@ -808,7 +913,37 @@
           <a:p>
             <a:pPr/>
             <a:r>
-              <a:t>Detection, interpretability, and governance each compound the problem rather than closing it. Detection infrastructure was designed to surface anomalies in the model, but language-model fluency suppresses the surface error signals it depends on. Interpretability makes model reasoning legible, but legibility and engagement are not the same thing. Fok and Weld show that explanations only support oversight when they enable verification, and they usually don't. Governance frameworks certify that the process was followed, which they do well, but they were calibrated for intentional non-compliance, not for the failure mode where every step is followed and the cognitive function is absent. The pattern is not non-compliance. The framework reports green because green is occurring. The table on the slide is the shift. From instrumenting the model, to instrumenting the function the model's safety properties depend on.</a:t>
+              <a:t>S5  60-75s  why current tooling misses it - all three COMPOUND</a:t>
+            </a:r>
+          </a:p>
+          <a:p>
+            <a:r>
+              <a:t>- detection: LLM fluency smooths over the surface errors it hunts</a:t>
+            </a:r>
+          </a:p>
+          <a:p>
+            <a:r>
+              <a:t>- interpretability: legible != engaged (Fok &amp; Weld - explanations help only when they let you verify)</a:t>
+            </a:r>
+          </a:p>
+          <a:p>
+            <a:r>
+              <a:t>- governance: tuned for rule-breaking, not for every-rule-followed-and-thinking-absent</a:t>
+            </a:r>
+          </a:p>
+          <a:p>
+            <a:r>
+              <a:t>[SLOW, FLAT] this isn't non-compliance - it's boredom / green because green is occurring</a:t>
+            </a:r>
+          </a:p>
+          <a:p>
+            <a:r>
+              <a:t>- the shift: from instrumenting the model to instrumenting the function safety depends on</a:t>
+            </a:r>
+          </a:p>
+          <a:p>
+            <a:r>
+              <a:t>-&gt; bridge to 6 (only if room lost): 'So what does instrumenting the oversight layer look like?'</a:t>
             </a:r>
           </a:p>
         </p:txBody>
@@ -878,7 +1013,27 @@
           <a:p>
             <a:pPr/>
             <a:r>
-              <a:t>Three candidate indicators get the agenda started. Correction-rate trajectory: the rate at which AI outputs receive substantive correction, tracked over deployment duration. Validation load: outputs requiring review per unit of reviewer capacity. Dependency accumulation: how many downstream workflow nodes depend on outputs passing a given checkpoint. The design constraint shaping all three is reviewer surveillance. A lot of resistance to oversight instrumentation, in my experience, comes from a reasonable concern that the moment you start measuring whether reviewers are paying attention, you have built a surveillance system pointed at individual people. The indicators here are designed to refuse that drift by construction. They report at the workflow or deployment level, not the reviewer level. The paper develops three requirements that keep instrumentation honest. Data architecture that makes individual-level access infeasible. Indicators that never wire into management evaluation or compensation. And threshold-triggered interventions that operate on aggregate workflow state. Without those guardrails, the cure becomes the disease. The interpretation discipline also matters. Declining correction rates can mean oversight degradation, or genuine system maturity, and discriminating those is its own protocol. The general design principle is on the slide. Satisfying the metric and exercising genuine oversight should be difficult to decouple. Goodhart's Law applies to oversight instrumentation as much as to the workflows it observes.</a:t>
+              <a:t>S6  60-75s  three engagement proxies, built to dodge surveillance</a:t>
+            </a:r>
+          </a:p>
+          <a:p>
+            <a:r>
+              <a:t>- correction trajectory / validation load / dependency accumulation</a:t>
+            </a:r>
+          </a:p>
+          <a:p>
+            <a:r>
+              <a:t>- structural + aggregate BY CONSTRUCTION - keeps measurement off individual reviewers (Section 6.3 guardrails)</a:t>
+            </a:r>
+          </a:p>
+          <a:p>
+            <a:r>
+              <a:t>- caveat: a falling correction rate = degrading OR matured; its own protocol</a:t>
+            </a:r>
+          </a:p>
+          <a:p>
+            <a:r>
+              <a:t>- design principle: metric &amp; real oversight HARD TO DECOUPLE - Goodhart applies to the instrument too</a:t>
             </a:r>
           </a:p>
         </p:txBody>
@@ -948,7 +1103,47 @@
           <a:p>
             <a:pPr/>
             <a:r>
-              <a:t>Five concrete implementations. Each can be built with current workflow infrastructure and existing logging. Seeded calibration checks inject pre-validated outputs into the review queue. The reviewer's disagreement rate on those items tracks their engagement on everything else. Onboarding-period baselines log new reviewers' correction patterns before they're calibrated to operational norms. A persistent gap means the operational baseline has drifted. Dependency surfacing puts consequence information in front of the reviewer at decision time. Decision-point logging instruments agentic systems at each irreversible action, not just the final output. Workload ceilings turn an observational indicator into an architectural enforcement mechanism. The routing system refuses additional work to a saturated reviewer. None of these are validated for governance certification yet. They are candidates to deploy, observe, and refine.</a:t>
+              <a:t>S7  60-75s  TIGHTEST - five mechanisms, all buildable today</a:t>
+            </a:r>
+          </a:p>
+          <a:p>
+            <a:r>
+              <a:t>- buildable with the workflow infra + logging you already have</a:t>
+            </a:r>
+          </a:p>
+          <a:p>
+            <a:r>
+              <a:t>- 01 seeded [SLOW - strongest]: disagreement rate on planted items tracks engagement on the rest</a:t>
+            </a:r>
+          </a:p>
+          <a:p>
+            <a:r>
+              <a:t>- 02 onboarding: log corrections before they calibrate - persistent gap = baseline drifted</a:t>
+            </a:r>
+          </a:p>
+          <a:p>
+            <a:r>
+              <a:t>- 03 dependency: consequence in front of reviewer at the moment of approval</a:t>
+            </a:r>
+          </a:p>
+          <a:p>
+            <a:r>
+              <a:t>- 04 decision-point: every irreversible action (agentic), not just final output</a:t>
+            </a:r>
+          </a:p>
+          <a:p>
+            <a:r>
+              <a:t>- 05 ceilings [SLOW]: indicator -&gt; enforcement; router refuses a saturated reviewer</a:t>
+            </a:r>
+          </a:p>
+          <a:p>
+            <a:r>
+              <a:t>- none validated for certification yet - candidates: deploy / watch / refine</a:t>
+            </a:r>
+          </a:p>
+          <a:p>
+            <a:r>
+              <a:t>(by beat 4 ~ 35-40s; if behind, jump to 05)</a:t>
             </a:r>
           </a:p>
         </p:txBody>
@@ -1018,7 +1213,37 @@
           <a:p>
             <a:pPr/>
             <a:r>
-              <a:t>What I'm asking for. Three partnership types, shaped by my time teaching and by my work in enterprise deployments. So these are specific asks, not generic ones. Deployment-context partners willing to instrument oversight quality in operational settings, under the structural-and-aggregate constraints I describe in the paper. Regulatory and standards partners working on how oversight requirements might be made functionally rather than procedurally auditable. Methodological partners with expertise in the cognitive dynamics of evaluative judgment under fluent-text review. The closing line is this. Process compliance was the right thing to measure when the risk was non-compliance. It is not the right thing to measure when the risk is procedural compliance coexisting with functional absence. The work is the measurement infrastructure that distinguishes those two states. The QR codes at the bottom are scannable now, and during Q&amp;A. Left, the full paper on OpenReview. Center, my LinkedIn. Right, the poster as a PDF. Thank you. I'm happy to take questions.</a:t>
+              <a:t>S8  60-75s  CLOSE - the ask, then the line</a:t>
+            </a:r>
+          </a:p>
+          <a:p>
+            <a:r>
+              <a:t>- three partners: deployment (structural + aggregate constraints) / regulatory (functionally, not procedurally, auditable - cf. EU AI Act Art 14) / methodological (cognitive dynamics of judgment under fluent-text review)</a:t>
+            </a:r>
+          </a:p>
+          <a:p>
+            <a:r>
+              <a:t>[SLOW, FULL FORM] process compliance was the right thing to measure when the risk was non-compliance</a:t>
+            </a:r>
+          </a:p>
+          <a:p>
+            <a:r>
+              <a:t>[PAUSE] it is not the right thing when the process is followed perfectly and the function is gone</a:t>
+            </a:r>
+          </a:p>
+          <a:p>
+            <a:r>
+              <a:t>- the work = the measurement infra that tells the two states apart</a:t>
+            </a:r>
+          </a:p>
+          <a:p>
+            <a:r>
+              <a:t>- QR: paper / LinkedIn / deck</a:t>
+            </a:r>
+          </a:p>
+          <a:p>
+            <a:r>
+              <a:t>Thank you. Happy to take questions. [step back half a step, hands down]</a:t>
             </a:r>
           </a:p>
         </p:txBody>

</xml_diff>

<commit_message>
Update AITC deck: fix QR codes (paper, LinkedIn); rebuild presenter notes to cover + Speak form
</commit_message>
<xml_diff>
--- a/slides/confirming_process_aitc_2026_slides.pptx
+++ b/slides/confirming_process_aitc_2026_slides.pptx
@@ -526,29 +526,13 @@
           <a:bodyPr/>
           <a:lstStyle/>
           <a:p>
-            <a:pPr/>
-            <a:r>
-              <a:t>S1  15-20s  SLOW, settle the room  (no 'thanks for having me')</a:t>
-            </a:r>
-          </a:p>
-          <a:p>
-            <a:r>
-              <a:t>- Brian Moriarty, Stevens - human oversight of AI, from IT architecture + governance</a:t>
-            </a:r>
-          </a:p>
-          <a:p>
-            <a:r>
-              <a:t>- the paper = a gap in how we OBSERVE the oversight function (inside the transparency + control infra we already use)</a:t>
-            </a:r>
-          </a:p>
-          <a:p>
-            <a:r>
-              <a:t>- records show review OCCURRED, not whether it was SUBSTANTIVE (unless someone notices)</a:t>
-            </a:r>
-          </a:p>
-          <a:p>
-            <a:r>
-              <a:t>- the two cases - real review vs rubber stamp - look identical from the outside</a:t>
+            <a:r>
+              <a:t>Name, what I do  (~20s)</a:t>
+            </a:r>
+          </a:p>
+          <a:p>
+            <a:r>
+              <a:t>Speak: Let's set context. Industry setting. A review occurred vs. what was substantive. From the outside, each appear identical. [SLOW]</a:t>
             </a:r>
           </a:p>
         </p:txBody>
@@ -616,49 +600,23 @@
           <a:bodyPr/>
           <a:lstStyle/>
           <a:p>
-            <a:pPr/>
-            <a:r>
-              <a:t>S2  75-90s  EARN THE ROOM</a:t>
-            </a:r>
-          </a:p>
-          <a:p>
-            <a:r>
-              <a:t>[PAUSE 3-5s after click - let them read]</a:t>
-            </a:r>
-          </a:p>
-          <a:p>
-            <a:r>
-              <a:t>- two sample records (abstractions from my finance work) / both pass audit / one engaged ~18 min, one signed off in 6 sec / infra can't tell which</a:t>
-            </a:r>
-          </a:p>
-          <a:p>
-            <a:r>
-              <a:t>[PAUSE after 'six seconds']</a:t>
-            </a:r>
-          </a:p>
-          <a:p>
-            <a:r>
-              <a:t>- partly about people - a human-nature matter, older than AI (the 'D' commit msg if you want it)</a:t>
-            </a:r>
-          </a:p>
-          <a:p>
-            <a:r>
-              <a:t>- the structural point: infra instruments the model + its artifacts, not the cognitive work that gives oversight its safety value</a:t>
-            </a:r>
-          </a:p>
-          <a:p>
-            <a:r>
-              <a:t>- human side + infra side COMPOUND -&gt; the measurement agenda</a:t>
-            </a:r>
-          </a:p>
-          <a:p>
-            <a:r>
-              <a:t>- [if asked on time] time = crudest proxy, gamed (tab open 18 min, nothing happened); engagement not observable -&gt; seeded catch-rate + structural conditions</a:t>
-            </a:r>
-          </a:p>
-          <a:p>
-            <a:r>
-              <a:t>(don't speak over their reading; don't apologize for the samples)</a:t>
+            <a:r>
+              <a:t>Two records, the reveal, the structural point  (~75s)</a:t>
+            </a:r>
+          </a:p>
+          <a:p>
+            <a:r>
+              <a:t>Speak: Here are two records from the same kind of work, abstractions from my finance experience. Both pass audit, both look clean. But one reviewer engaged for eighteen minutes. The other signed off in six seconds. [PAUSE on the reveal] And the infrastructure can't tell which is which. Part of this is human nature, older than AI. The structural point: we instrument the model and its outputs, not the cognitive work that gives oversight its value. So the two failures compound.</a:t>
+            </a:r>
+          </a:p>
+          <a:p>
+            <a:r>
+              <a:t>Analogy: a commit message that was just the letter "D". Required, entered, logged compliant, nothing real survived.</a:t>
+            </a:r>
+          </a:p>
+          <a:p>
+            <a:r>
+              <a:t>If asked (time): time is the crudest proxy and it's gameable. You can leave a doc open eighteen minutes and do nothing. I measure whether reviewers catch problems I've planted instead. Offline after.</a:t>
             </a:r>
           </a:p>
         </p:txBody>
@@ -726,29 +684,23 @@
           <a:bodyPr/>
           <a:lstStyle/>
           <a:p>
-            <a:pPr/>
-            <a:r>
-              <a:t>S3  60s  three claims, #2 is the anchor</a:t>
-            </a:r>
-          </a:p>
-          <a:p>
-            <a:r>
-              <a:t>- 1: oversight is a system component, not an on/off switch (supervisory control: state / workload / calibration / failure modes)</a:t>
-            </a:r>
-          </a:p>
-          <a:p>
-            <a:r>
-              <a:t>- 2 [SLOW, FULL FORM]: it degrades predictably; the degraded reviewer and the engaged reviewer are observationally identical, absent demonstrative evidence</a:t>
-            </a:r>
-          </a:p>
-          <a:p>
-            <a:r>
-              <a:t>- 3: detection / interpretability / governance watch the wrong layer (model + outputs); extend that transparency to the oversight layer itself</a:t>
-            </a:r>
-          </a:p>
-          <a:p>
-            <a:r>
-              <a:t>-&gt; bridge to 4 (only if room lost): 'Take claim two first.'</a:t>
+            <a:r>
+              <a:t>Three claims: not a switch, identical record, wrong layer  (~75s)</a:t>
+            </a:r>
+          </a:p>
+          <a:p>
+            <a:r>
+              <a:t>Speak: Three claims hold up the paper. First, oversight isn't a switch you flip on. It's a component in a system, and it can quietly stop working while everything still looks connected. Second, when it degrades, the degraded reviewer and the engaged one leave the exact same record. [SLOW] Nothing tells them apart. Third, our big tools, detection, interpretability, governance, all watch the model. None watch the person doing the checking. We instrumented the wrong layer.</a:t>
+            </a:r>
+          </a:p>
+          <a:p>
+            <a:r>
+              <a:t>Analogy: two students hand in the same filled-out worksheet; the page can't show who copied. Or: every camera on the vault, none on the guard.</a:t>
+            </a:r>
+          </a:p>
+          <a:p>
+            <a:r>
+              <a:t>If asked (Bainbridge): the human side is old news and I build on it; what's new is that all our tooling watches the model. Trade refs after.</a:t>
             </a:r>
           </a:p>
         </p:txBody>
@@ -816,34 +768,23 @@
           <a:bodyPr/>
           <a:lstStyle/>
           <a:p>
-            <a:pPr/>
-            <a:r>
-              <a:t>S4  75-90s  SECOND REVEAL</a:t>
-            </a:r>
-          </a:p>
-          <a:p>
-            <a:r>
-              <a:t>- P1 substantive: corrections track quality</a:t>
-            </a:r>
-          </a:p>
-          <a:p>
-            <a:r>
-              <a:t>- P2 procedural: scanning replaces scrutiny; correction rate drops because the BAR ROSE, not the work</a:t>
-            </a:r>
-          </a:p>
-          <a:p>
-            <a:r>
-              <a:t>- P3 formality: approval logged with nothing behind it - controller -&gt; confirmer</a:t>
-            </a:r>
-          </a:p>
-          <a:p>
-            <a:r>
-              <a:t>[POINT at top bar, HOLD] record identical P1 = P3; audit finds every step documented, every approval logged</a:t>
-            </a:r>
-          </a:p>
-          <a:p>
-            <a:r>
-              <a:t>[PAUSE] no alarm, no threshold crossed, no incident</a:t>
+            <a:r>
+              <a:t>Three phases, the record stays uniform  (~85s)</a:t>
+            </a:r>
+          </a:p>
+          <a:p>
+            <a:r>
+              <a:t>Speak: It degrades in three phases. At first the reviewer does real work, reading closely, catching errors, sending things back. Then the corrections fall off and it looks like the AI got better. It didn't. The reviewer's bar dropped. [POINT at the bar, HOLD] By the end they're just confirming. The approval is a reflex. And the part that matters: the record is identical across all three phases. No alarm, no incident.</a:t>
+            </a:r>
+          </a:p>
+          <a:p>
+            <a:r>
+              <a:t>Analogy: three chest X-rays all stamped healthy when only the first one is. The label never changed; the patient did.</a:t>
+            </a:r>
+          </a:p>
+          <a:p>
+            <a:r>
+              <a:t>If asked (evidence): the automation literature and Green's review of forty-one policies back the pattern, and my cohort is testing it now. Share after.</a:t>
             </a:r>
           </a:p>
         </p:txBody>
@@ -911,39 +852,23 @@
           <a:bodyPr/>
           <a:lstStyle/>
           <a:p>
-            <a:pPr/>
-            <a:r>
-              <a:t>S5  60-75s  why current tooling misses it - all three COMPOUND</a:t>
-            </a:r>
-          </a:p>
-          <a:p>
-            <a:r>
-              <a:t>- detection: LLM fluency smooths over the surface errors it hunts</a:t>
-            </a:r>
-          </a:p>
-          <a:p>
-            <a:r>
-              <a:t>- interpretability: legible != engaged (Fok &amp; Weld - explanations help only when they let you verify)</a:t>
-            </a:r>
-          </a:p>
-          <a:p>
-            <a:r>
-              <a:t>- governance: tuned for rule-breaking, not for every-rule-followed-and-thinking-absent</a:t>
-            </a:r>
-          </a:p>
-          <a:p>
-            <a:r>
-              <a:t>[SLOW, FLAT] this isn't non-compliance - it's boredom / green because green is occurring</a:t>
-            </a:r>
-          </a:p>
-          <a:p>
-            <a:r>
-              <a:t>- the shift: from instrumenting the model to instrumenting the function safety depends on</a:t>
-            </a:r>
-          </a:p>
-          <a:p>
-            <a:r>
-              <a:t>-&gt; bridge to 6 (only if room lost): 'So what does instrumenting the oversight layer look like?'</a:t>
+            <a:r>
+              <a:t>Every fix points at the model; the shift  (~55s)</a:t>
+            </a:r>
+          </a:p>
+          <a:p>
+            <a:r>
+              <a:t>Speak: Look at what we reach for when something goes wrong. Tools that flag when the AI is off. Tools that crack the model open to see how it reasoned. Policies that require a sign-off. Every one points at the model. None watch the person checking it, so each one widens the same gap. This isn't someone breaking the rules. It's boredom. The light's green because green is what's happening. The shift: stop measuring the model, start measuring whether the review still happens.</a:t>
+            </a:r>
+          </a:p>
+          <a:p>
+            <a:r>
+              <a:t>Analogy: we keep polishing the gauges; the question is whether anyone's reading them.</a:t>
+            </a:r>
+          </a:p>
+          <a:p>
+            <a:r>
+              <a:t>If asked (won't better tooling catch it): those tools watch the model; the gap is the person, so they miss it by design. Cases after.</a:t>
             </a:r>
           </a:p>
         </p:txBody>
@@ -1011,29 +936,23 @@
           <a:bodyPr/>
           <a:lstStyle/>
           <a:p>
-            <a:pPr/>
-            <a:r>
-              <a:t>S6  60-75s  three engagement proxies, built to dodge surveillance</a:t>
-            </a:r>
-          </a:p>
-          <a:p>
-            <a:r>
-              <a:t>- correction trajectory / validation load / dependency accumulation</a:t>
-            </a:r>
-          </a:p>
-          <a:p>
-            <a:r>
-              <a:t>- structural + aggregate BY CONSTRUCTION - keeps measurement off individual reviewers (Section 6.3 guardrails)</a:t>
-            </a:r>
-          </a:p>
-          <a:p>
-            <a:r>
-              <a:t>- caveat: a falling correction rate = degrading OR matured; its own protocol</a:t>
-            </a:r>
-          </a:p>
-          <a:p>
-            <a:r>
-              <a:t>- design principle: metric &amp; real oversight HARD TO DECOUPLE - Goodhart applies to the instrument too</a:t>
+            <a:r>
+              <a:t>Sweep three indicators, all on the workflow  (~60s)</a:t>
+            </a:r>
+          </a:p>
+          <a:p>
+            <a:r>
+              <a:t>Speak: Three things you can actually measure. How often reviewers correct the AI, and whether that's sliding over time, that's your early warning. How many items each reviewer has to clear, because overload is where attention dies. And how much downstream work rides on a single approval. All of it reported on the workflow, never on a person, and built so you can't hit the number without doing the real reviewing.</a:t>
+            </a:r>
+          </a:p>
+          <a:p>
+            <a:r>
+              <a:t>Analogy: a traffic sensor that counts cars but can't read a plate, by design.</a:t>
+            </a:r>
+          </a:p>
+          <a:p>
+            <a:r>
+              <a:t>If asked (surveillance): it only ever reports on the workflow, never a named person, and that's built into the data, not just promised. Safeguards after.</a:t>
             </a:r>
           </a:p>
         </p:txBody>
@@ -1101,49 +1020,18 @@
           <a:bodyPr/>
           <a:lstStyle/>
           <a:p>
-            <a:pPr/>
-            <a:r>
-              <a:t>S7  60-75s  TIGHTEST - five mechanisms, all buildable today</a:t>
-            </a:r>
-          </a:p>
-          <a:p>
-            <a:r>
-              <a:t>- buildable with the workflow infra + logging you already have</a:t>
-            </a:r>
-          </a:p>
-          <a:p>
-            <a:r>
-              <a:t>- 01 seeded [SLOW - strongest]: disagreement rate on planted items tracks engagement on the rest</a:t>
-            </a:r>
-          </a:p>
-          <a:p>
-            <a:r>
-              <a:t>- 02 onboarding: log corrections before they calibrate - persistent gap = baseline drifted</a:t>
-            </a:r>
-          </a:p>
-          <a:p>
-            <a:r>
-              <a:t>- 03 dependency: consequence in front of reviewer at the moment of approval</a:t>
-            </a:r>
-          </a:p>
-          <a:p>
-            <a:r>
-              <a:t>- 04 decision-point: every irreversible action (agentic), not just final output</a:t>
-            </a:r>
-          </a:p>
-          <a:p>
-            <a:r>
-              <a:t>- 05 ceilings [SLOW]: indicator -&gt; enforcement; router refuses a saturated reviewer</a:t>
-            </a:r>
-          </a:p>
-          <a:p>
-            <a:r>
-              <a:t>- none validated for certification yet - candidates: deploy / watch / refine</a:t>
-            </a:r>
-          </a:p>
-          <a:p>
-            <a:r>
-              <a:t>(by beat 4 ~ 35-40s; if behind, jump to 05)</a:t>
+            <a:r>
+              <a:t>Name five fast, dwell on two  (~75s)</a:t>
+            </a:r>
+          </a:p>
+          <a:p>
+            <a:r>
+              <a:t>Speak: Five things you can build today with logging you already have. Name them fast: seeded checks, onboarding baselines, stakes shown at decision time, irreversible-action logging, workload caps. Two to dwell on. Seeded checks: plant items you've already reviewed and see who catches them, like a secret shopper who can't be spotted, so everyone gets treated right. And irreversible-action logging: for AI agents, record every irreversible step, not just the final output, because the damage is usually in the steps, an email sent or a record deleted, that the output never shows. None of these are proven yet. They're candidates to deploy, watch, and refine.</a:t>
+            </a:r>
+          </a:p>
+          <a:p>
+            <a:r>
+              <a:t>If asked (gaming): the seeded checks can't be faked, you have to actually look. The rest report system strain, not a score on anyone. Offline.</a:t>
             </a:r>
           </a:p>
         </p:txBody>
@@ -1211,39 +1099,23 @@
           <a:bodyPr/>
           <a:lstStyle/>
           <a:p>
-            <a:pPr/>
-            <a:r>
-              <a:t>S8  60-75s  CLOSE - the ask, then the line</a:t>
-            </a:r>
-          </a:p>
-          <a:p>
-            <a:r>
-              <a:t>- three partners: deployment (structural + aggregate constraints) / regulatory (functionally, not procedurally, auditable - cf. EU AI Act Art 14) / methodological (cognitive dynamics of judgment under fluent-text review)</a:t>
-            </a:r>
-          </a:p>
-          <a:p>
-            <a:r>
-              <a:t>[SLOW, FULL FORM] process compliance was the right thing to measure when the risk was non-compliance</a:t>
-            </a:r>
-          </a:p>
-          <a:p>
-            <a:r>
-              <a:t>[PAUSE] it is not the right thing when the process is followed perfectly and the function is gone</a:t>
-            </a:r>
-          </a:p>
-          <a:p>
-            <a:r>
-              <a:t>- the work = the measurement infra that tells the two states apart</a:t>
-            </a:r>
-          </a:p>
-          <a:p>
-            <a:r>
-              <a:t>- QR: paper / LinkedIn / deck</a:t>
-            </a:r>
-          </a:p>
-          <a:p>
-            <a:r>
-              <a:t>Thank you. Happy to take questions. [step back half a step, hands down]</a:t>
+            <a:r>
+              <a:t>Three partners, then the close  (~65s)</a:t>
+            </a:r>
+          </a:p>
+          <a:p>
+            <a:r>
+              <a:t>Speak: I'm looking for three kinds of partner: deployment, regulatory, methodological. [SLOW] And to close: process compliance was the right thing to measure when the risk was non-compliance. It is not the right thing to measure when the process is followed perfectly and the function is gone. The work is the infrastructure that tells those two states apart.</a:t>
+            </a:r>
+          </a:p>
+          <a:p>
+            <a:r>
+              <a:t>Fallback if you blank: we built the measure for cheating; the risk now is the opposite, perfect compliance with empty function.</a:t>
+            </a:r>
+          </a:p>
+          <a:p>
+            <a:r>
+              <a:t>If asked (sole-author, no data): the gap I'm naming rests on published work, and the experiment that builds on it is underway. Continue after.</a:t>
             </a:r>
           </a:p>
         </p:txBody>
@@ -2457,7 +2329,7 @@
               </a:defRPr>
             </a:pPr>
             <a:r>
-              <a:t>Stevens </a:t>
+              <a:t xml:space="preserve">Stevens </a:t>
             </a:r>
             <a:r>
               <a:rPr b="0">
@@ -4543,7 +4415,7 @@
               </a:defRPr>
             </a:pPr>
             <a:r>
-              <a:t>One review took </a:t>
+              <a:t xml:space="preserve">One review took </a:t>
             </a:r>
             <a:r>
               <a:rPr b="1">
@@ -4551,10 +4423,10 @@
                   <a:srgbClr val="B8451E"/>
                 </a:solidFill>
               </a:rPr>
-              <a:t>eighteen minutes </a:t>
-            </a:r>
-            <a:r>
-              <a:t>of substantive evaluation. One took </a:t>
+              <a:t xml:space="preserve">eighteen minutes </a:t>
+            </a:r>
+            <a:r>
+              <a:t xml:space="preserve">of substantive evaluation. One took </a:t>
             </a:r>
             <a:r>
               <a:rPr b="1">
@@ -4562,7 +4434,7 @@
                   <a:srgbClr val="B8451E"/>
                 </a:solidFill>
               </a:rPr>
-              <a:t>six seconds </a:t>
+              <a:t xml:space="preserve">six seconds </a:t>
             </a:r>
             <a:r>
               <a:t>of procedural confirmation. The audit record does not distinguish them.</a:t>
@@ -4932,11 +4804,11 @@
               </a:defRPr>
             </a:pPr>
             <a:r>
-              <a:t>The oversight function is a </a:t>
+              <a:t xml:space="preserve">The oversight function is a </a:t>
             </a:r>
             <a:r>
               <a:rPr b="1"/>
-              <a:t>system component </a:t>
+              <a:t xml:space="preserve">system component </a:t>
             </a:r>
             <a:r>
               <a:t>, not a binary switch.</a:t>
@@ -5036,7 +4908,7 @@
               </a:defRPr>
             </a:pPr>
             <a:r>
-              <a:t>It degrades predictably under operational conditions. The degraded state and the functional state leave </a:t>
+              <a:t xml:space="preserve">It degrades predictably under operational conditions. The degraded state and the functional state leave </a:t>
             </a:r>
             <a:r>
               <a:rPr b="1">
@@ -5144,7 +5016,7 @@
               </a:defRPr>
             </a:pPr>
             <a:r>
-              <a:t>Current detection, interpretability, and governance methods do not close the gap, because they </a:t>
+              <a:t xml:space="preserve">Current detection, interpretability, and governance methods do not close the gap, because they </a:t>
             </a:r>
             <a:r>
               <a:rPr b="1">
@@ -5152,7 +5024,7 @@
                   <a:srgbClr val="B8451E"/>
                 </a:solidFill>
               </a:rPr>
-              <a:t>instrument the wrong layer </a:t>
+              <a:t xml:space="preserve">instrument the wrong layer </a:t>
             </a:r>
             <a:r>
               <a:t>.</a:t>
@@ -13449,7 +13321,7 @@
               </a:defRPr>
             </a:pPr>
             <a:r>
-              <a:t>Deployment-context partners </a:t>
+              <a:t xml:space="preserve">Deployment-context partners </a:t>
             </a:r>
             <a:r>
               <a:rPr b="0">
@@ -13535,7 +13407,7 @@
               </a:defRPr>
             </a:pPr>
             <a:r>
-              <a:t>Regulatory and standards partners </a:t>
+              <a:t xml:space="preserve">Regulatory and standards partners </a:t>
             </a:r>
             <a:r>
               <a:rPr b="0">
@@ -13621,7 +13493,7 @@
               </a:defRPr>
             </a:pPr>
             <a:r>
-              <a:t>Methodological partners </a:t>
+              <a:t xml:space="preserve">Methodological partners </a:t>
             </a:r>
             <a:r>
               <a:rPr b="0">

</xml_diff>